<commit_message>
Add model experimentation framework: 9 models, comparison script, configs
</commit_message>
<xml_diff>
--- a/Research_Summarizer_Project.pptx
+++ b/Research_Summarizer_Project.pptx
@@ -153,7 +153,7 @@
   <pc:docChgLst>
     <pc:chgData name="Ruhama Y. Mekonnen" userId="f55263af839ded1e" providerId="LiveId" clId="{5A8E9F9C-59A7-4A83-9D39-F3F10297DD2D}"/>
     <pc:docChg chg="undo redo custSel addSld modSld">
-      <pc:chgData name="Ruhama Y. Mekonnen" userId="f55263af839ded1e" providerId="LiveId" clId="{5A8E9F9C-59A7-4A83-9D39-F3F10297DD2D}" dt="2026-01-31T07:59:57.557" v="160" actId="20577"/>
+      <pc:chgData name="Ruhama Y. Mekonnen" userId="f55263af839ded1e" providerId="LiveId" clId="{5A8E9F9C-59A7-4A83-9D39-F3F10297DD2D}" dt="2026-01-31T08:13:08.019" v="161" actId="20577"/>
       <pc:docMkLst>
         <pc:docMk/>
       </pc:docMkLst>
@@ -337,6 +337,21 @@
             <pc:docMk/>
             <pc:sldMk cId="0" sldId="264"/>
             <ac:spMk id="3" creationId="{00000000-0000-0000-0000-000000000000}"/>
+          </ac:spMkLst>
+        </pc:spChg>
+      </pc:sldChg>
+      <pc:sldChg chg="modSp mod">
+        <pc:chgData name="Ruhama Y. Mekonnen" userId="f55263af839ded1e" providerId="LiveId" clId="{5A8E9F9C-59A7-4A83-9D39-F3F10297DD2D}" dt="2026-01-31T08:13:08.019" v="161" actId="20577"/>
+        <pc:sldMkLst>
+          <pc:docMk/>
+          <pc:sldMk cId="0" sldId="265"/>
+        </pc:sldMkLst>
+        <pc:spChg chg="mod">
+          <ac:chgData name="Ruhama Y. Mekonnen" userId="f55263af839ded1e" providerId="LiveId" clId="{5A8E9F9C-59A7-4A83-9D39-F3F10297DD2D}" dt="2026-01-31T08:13:08.019" v="161" actId="20577"/>
+          <ac:spMkLst>
+            <pc:docMk/>
+            <pc:sldMk cId="0" sldId="265"/>
+            <ac:spMk id="2" creationId="{00000000-0000-0000-0000-000000000000}"/>
           </ac:spMkLst>
         </pc:spChg>
       </pc:sldChg>
@@ -3477,8 +3492,9 @@
           <a:lstStyle/>
           <a:p>
             <a:r>
-              <a:t>Hybrid Mode: Best of Both Worlds</a:t>
-            </a:r>
+              <a:t>Hybrid Mode</a:t>
+            </a:r>
+            <a:endParaRPr dirty="0"/>
           </a:p>
         </p:txBody>
       </p:sp>
@@ -4600,7 +4616,7 @@
           </a:p>
           <a:p>
             <a:r>
-              <a:rPr lang="en-US"/>
+              <a:rPr lang="en-US" dirty="0"/>
               <a:t> </a:t>
             </a:r>
             <a:r>
@@ -4609,15 +4625,7 @@
             </a:r>
             <a:r>
               <a:rPr lang="en-US" dirty="0"/>
-              <a:t> - </a:t>
-            </a:r>
-            <a:r>
-              <a:rPr lang="en-US"/>
-              <a:t>LED needs </a:t>
-            </a:r>
-            <a:r>
-              <a:rPr lang="en-US" dirty="0"/>
-              <a:t>VRAM, poor performance on CPU-only machines</a:t>
+              <a:t> - LED needs VRAM, poor performance on CPU-only machines</a:t>
             </a:r>
           </a:p>
           <a:p>
@@ -4698,6 +4706,7 @@
               <a:defRPr sz="2000"/>
             </a:pPr>
             <a:r>
+              <a:rPr dirty="0"/>
               <a:t>Who benefits from this system?</a:t>
             </a:r>
           </a:p>
@@ -4709,6 +4718,7 @@
               <a:defRPr sz="1800"/>
             </a:pPr>
             <a:r>
+              <a:rPr dirty="0"/>
               <a:t>Graduate students reviewing 100+ papers for literature reviews</a:t>
             </a:r>
           </a:p>
@@ -4720,6 +4730,7 @@
               <a:defRPr sz="1800"/>
             </a:pPr>
             <a:r>
+              <a:rPr dirty="0"/>
               <a:t>R&amp;D teams in pharma/biotech (confidential documents)</a:t>
             </a:r>
           </a:p>
@@ -4731,6 +4742,7 @@
               <a:defRPr sz="1800"/>
             </a:pPr>
             <a:r>
+              <a:rPr dirty="0"/>
               <a:t>Legal professionals analyzing patent documents</a:t>
             </a:r>
           </a:p>
@@ -4741,16 +4753,17 @@
               </a:spcAft>
               <a:defRPr sz="2000"/>
             </a:pPr>
-            <a:endParaRPr/>
-          </a:p>
-          <a:p>
-            <a:pPr>
-              <a:spcAft>
-                <a:spcPts val="800"/>
-              </a:spcAft>
-              <a:defRPr sz="2000"/>
-            </a:pPr>
-            <a:r>
+            <a:endParaRPr dirty="0"/>
+          </a:p>
+          <a:p>
+            <a:pPr>
+              <a:spcAft>
+                <a:spcPts val="800"/>
+              </a:spcAft>
+              <a:defRPr sz="2000"/>
+            </a:pPr>
+            <a:r>
+              <a:rPr dirty="0"/>
               <a:t>Key advantages:</a:t>
             </a:r>
           </a:p>
@@ -4762,6 +4775,7 @@
               <a:defRPr sz="1800"/>
             </a:pPr>
             <a:r>
+              <a:rPr dirty="0"/>
               <a:t>10x faster than manual reading</a:t>
             </a:r>
           </a:p>
@@ -4773,6 +4787,7 @@
               <a:defRPr sz="1800"/>
             </a:pPr>
             <a:r>
+              <a:rPr dirty="0"/>
               <a:t>Privacy-preserving (no cloud APIs)</a:t>
             </a:r>
           </a:p>
@@ -4784,6 +4799,7 @@
               <a:defRPr sz="1800"/>
             </a:pPr>
             <a:r>
+              <a:rPr dirty="0"/>
               <a:t>Quantitatively validated (ROUGE scores)</a:t>
             </a:r>
           </a:p>

</xml_diff>

<commit_message>
feat: Add initial test script for abstractive summarization and record experiment results for various models.
</commit_message>
<xml_diff>
--- a/Research_Summarizer_Project.pptx
+++ b/Research_Summarizer_Project.pptx
@@ -3492,9 +3492,9 @@
           <a:lstStyle/>
           <a:p>
             <a:r>
+              <a:rPr dirty="0"/>
               <a:t>Hybrid Mode</a:t>
             </a:r>
-            <a:endParaRPr dirty="0"/>
           </a:p>
         </p:txBody>
       </p:sp>
@@ -3859,7 +3859,16 @@
               <a:defRPr sz="2000"/>
             </a:pPr>
             <a:r>
-              <a:t>Component 1: KeyBERT (Keyword Extraction)</a:t>
+              <a:rPr dirty="0"/>
+              <a:t>Component 1: </a:t>
+            </a:r>
+            <a:r>
+              <a:rPr dirty="0" err="1"/>
+              <a:t>KeyBERT</a:t>
+            </a:r>
+            <a:r>
+              <a:rPr dirty="0"/>
+              <a:t> (Keyword Extraction)</a:t>
             </a:r>
           </a:p>
           <a:p>
@@ -3870,6 +3879,7 @@
               <a:defRPr sz="1800"/>
             </a:pPr>
             <a:r>
+              <a:rPr dirty="0"/>
               <a:t>Uses sentence-transformers (all-MiniLM-L6-v2)</a:t>
             </a:r>
           </a:p>
@@ -3881,6 +3891,7 @@
               <a:defRPr sz="1800"/>
             </a:pPr>
             <a:r>
+              <a:rPr dirty="0"/>
               <a:t>Extracts top 10 statistically significant keywords</a:t>
             </a:r>
           </a:p>
@@ -3891,17 +3902,26 @@
               </a:spcAft>
               <a:defRPr sz="2000"/>
             </a:pPr>
-            <a:endParaRPr/>
-          </a:p>
-          <a:p>
-            <a:pPr>
-              <a:spcAft>
-                <a:spcPts val="800"/>
-              </a:spcAft>
-              <a:defRPr sz="2000"/>
-            </a:pPr>
-            <a:r>
-              <a:t>Component 2: Ollama LLM (llama3.2)</a:t>
+            <a:endParaRPr dirty="0"/>
+          </a:p>
+          <a:p>
+            <a:pPr>
+              <a:spcAft>
+                <a:spcPts val="800"/>
+              </a:spcAft>
+              <a:defRPr sz="2000"/>
+            </a:pPr>
+            <a:r>
+              <a:rPr dirty="0"/>
+              <a:t>Component 2: </a:t>
+            </a:r>
+            <a:r>
+              <a:rPr dirty="0" err="1"/>
+              <a:t>Ollama</a:t>
+            </a:r>
+            <a:r>
+              <a:rPr dirty="0"/>
+              <a:t> LLM (llama3.2)</a:t>
             </a:r>
           </a:p>
           <a:p>
@@ -3912,6 +3932,7 @@
               <a:defRPr sz="1800"/>
             </a:pPr>
             <a:r>
+              <a:rPr dirty="0"/>
               <a:t>Generates natural language analysis from keywords</a:t>
             </a:r>
           </a:p>
@@ -3923,7 +3944,16 @@
               <a:defRPr sz="1800"/>
             </a:pPr>
             <a:r>
-              <a:t>Runs locally via Ollama REST API</a:t>
+              <a:rPr dirty="0"/>
+              <a:t>Runs locally via </a:t>
+            </a:r>
+            <a:r>
+              <a:rPr dirty="0" err="1"/>
+              <a:t>Ollama</a:t>
+            </a:r>
+            <a:r>
+              <a:rPr dirty="0"/>
+              <a:t> REST API</a:t>
             </a:r>
           </a:p>
           <a:p>
@@ -3934,26 +3964,36 @@
               <a:defRPr sz="1800"/>
             </a:pPr>
             <a:r>
-              <a:t>Fallback to 'keywords only' if Ollama offline</a:t>
-            </a:r>
-          </a:p>
-          <a:p>
-            <a:pPr>
-              <a:spcAft>
-                <a:spcPts val="800"/>
-              </a:spcAft>
-              <a:defRPr sz="2000"/>
-            </a:pPr>
-            <a:endParaRPr/>
-          </a:p>
-          <a:p>
-            <a:pPr>
-              <a:spcAft>
-                <a:spcPts val="800"/>
-              </a:spcAft>
-              <a:defRPr sz="2000"/>
-            </a:pPr>
-            <a:r>
+              <a:rPr dirty="0"/>
+              <a:t>Fallback to 'keywords only' if </a:t>
+            </a:r>
+            <a:r>
+              <a:rPr dirty="0" err="1"/>
+              <a:t>Ollama</a:t>
+            </a:r>
+            <a:r>
+              <a:rPr dirty="0"/>
+              <a:t> offline</a:t>
+            </a:r>
+          </a:p>
+          <a:p>
+            <a:pPr>
+              <a:spcAft>
+                <a:spcPts val="800"/>
+              </a:spcAft>
+              <a:defRPr sz="2000"/>
+            </a:pPr>
+            <a:endParaRPr dirty="0"/>
+          </a:p>
+          <a:p>
+            <a:pPr>
+              <a:spcAft>
+                <a:spcPts val="800"/>
+              </a:spcAft>
+              <a:defRPr sz="2000"/>
+            </a:pPr>
+            <a:r>
+              <a:rPr dirty="0"/>
               <a:t>Why this combination? Fast extraction + contextual understanding</a:t>
             </a:r>
           </a:p>

</xml_diff>